<commit_message>
[MSC-45] Introduce operator Registry integration and notification lifecycle
Consolidate Registry storage/protocol/client services, claim recovery and
packaging integration with notifications, profile bootstrap and operator UI
snapshots.

Original-snapshot: b554d1b658d2db2aa589aa7d76756caa6af5bd97

Tasks: fssrepository/myscoutee-roadmap#45
</commit_message>
<xml_diff>
--- a/plans/pitch/output/myscoutee_network_pitch.pptx
+++ b/plans/pitch/output/myscoutee_network_pitch.pptx
@@ -69,7 +69,7 @@
         <p:txBody>
           <a:bodyPr/>
           <a:p>
-            <a:fld id="{EA274450-2339-4B85-8575-79838227C0D3}" type="slidenum">
+            <a:fld id="{F69ED832-67E2-4534-855D-8B3005F643BD}" type="slidenum">
               <a:t>&lt;#&gt;</a:t>
             </a:fld>
           </a:p>
@@ -257,7 +257,7 @@
         <p:txBody>
           <a:bodyPr/>
           <a:p>
-            <a:fld id="{4367E438-C47C-4C39-A0CB-4D334DE292DF}" type="slidenum">
+            <a:fld id="{F5BB22AF-A5BA-40D7-A965-DAE5FE2EBAE7}" type="slidenum">
               <a:t>&lt;#&gt;</a:t>
             </a:fld>
           </a:p>
@@ -513,7 +513,7 @@
         <p:txBody>
           <a:bodyPr/>
           <a:p>
-            <a:fld id="{83576FF9-57FA-4517-A622-7869983025C5}" type="slidenum">
+            <a:fld id="{975615F6-D0A3-4797-A7F9-39F3C4D15627}" type="slidenum">
               <a:t>&lt;#&gt;</a:t>
             </a:fld>
           </a:p>
@@ -837,7 +837,7 @@
         <p:txBody>
           <a:bodyPr/>
           <a:p>
-            <a:fld id="{8E3B5A12-0510-4799-9285-AB9B900BC0AC}" type="slidenum">
+            <a:fld id="{8A6280B2-9B2C-4916-AC9F-A95567742B99}" type="slidenum">
               <a:t>&lt;#&gt;</a:t>
             </a:fld>
           </a:p>
@@ -994,7 +994,7 @@
         <p:txBody>
           <a:bodyPr/>
           <a:p>
-            <a:fld id="{2893EA01-00BC-4A7A-BD52-C39B475514C6}" type="slidenum">
+            <a:fld id="{9D90D4EB-8894-4924-BEFC-C33BD9445D84}" type="slidenum">
               <a:t>&lt;#&gt;</a:t>
             </a:fld>
           </a:p>
@@ -1148,7 +1148,7 @@
         <p:txBody>
           <a:bodyPr/>
           <a:p>
-            <a:fld id="{C042E7BB-4327-451B-A85E-FA1E6A6BD297}" type="slidenum">
+            <a:fld id="{2725F1CE-AC09-48BF-8F24-D0206B0EECC2}" type="slidenum">
               <a:t>&lt;#&gt;</a:t>
             </a:fld>
           </a:p>
@@ -1336,7 +1336,7 @@
         <p:txBody>
           <a:bodyPr/>
           <a:p>
-            <a:fld id="{895668CD-E78F-44B4-9374-C07A085CC7C1}" type="slidenum">
+            <a:fld id="{D374057A-605A-488D-9BD6-2AC665ED5C30}" type="slidenum">
               <a:t>&lt;#&gt;</a:t>
             </a:fld>
           </a:p>
@@ -1456,7 +1456,7 @@
         <p:txBody>
           <a:bodyPr/>
           <a:p>
-            <a:fld id="{969B4966-9CBE-456C-8ED5-84935ACD91EC}" type="slidenum">
+            <a:fld id="{0AB6F795-A722-4C9C-AEBA-10E8C4BD2069}" type="slidenum">
               <a:t>&lt;#&gt;</a:t>
             </a:fld>
           </a:p>
@@ -1576,7 +1576,7 @@
         <p:txBody>
           <a:bodyPr/>
           <a:p>
-            <a:fld id="{F889E64F-132A-4344-B340-87B50E9ABA73}" type="slidenum">
+            <a:fld id="{F6DF14B5-0AD9-4569-95D6-C88772BC1F3E}" type="slidenum">
               <a:t>&lt;#&gt;</a:t>
             </a:fld>
           </a:p>
@@ -1798,7 +1798,7 @@
         <p:txBody>
           <a:bodyPr/>
           <a:p>
-            <a:fld id="{51281DED-226F-46E1-B6BA-79A251B3539F}" type="slidenum">
+            <a:fld id="{5B4CC3A8-F1F9-4865-BFF8-F0CD389542EE}" type="slidenum">
               <a:t>&lt;#&gt;</a:t>
             </a:fld>
           </a:p>
@@ -2020,7 +2020,7 @@
         <p:txBody>
           <a:bodyPr/>
           <a:p>
-            <a:fld id="{2987EBBE-3DCF-4A04-9C10-3DCC5F2A990E}" type="slidenum">
+            <a:fld id="{A50410D8-4E17-4CAF-8760-9F77A844E2EC}" type="slidenum">
               <a:t>&lt;#&gt;</a:t>
             </a:fld>
           </a:p>
@@ -2242,7 +2242,7 @@
         <p:txBody>
           <a:bodyPr/>
           <a:p>
-            <a:fld id="{A66CC3B4-E84F-4D8D-A151-DFF318FD55FF}" type="slidenum">
+            <a:fld id="{6318C235-0306-4F57-8C46-660B75E6DEDF}" type="slidenum">
               <a:t>&lt;#&gt;</a:t>
             </a:fld>
           </a:p>
@@ -2654,7 +2654,7 @@
             <a:pPr algn="r">
               <a:buNone/>
             </a:pPr>
-            <a:fld id="{7DB99BE9-95CF-4996-A3C2-CA185DFFD792}" type="slidenum">
+            <a:fld id="{9EB019CE-9033-4BE2-8FF5-A957454506CD}" type="slidenum">
               <a:rPr b="0" lang="en-US" sz="1400" spc="-1" strike="noStrike">
                 <a:latin typeface="Times New Roman"/>
               </a:rPr>

</xml_diff>